<commit_message>
refactord for readability, improved features_block more
</commit_message>
<xml_diff>
--- a/happyvale_brochure_v3.pptx
+++ b/happyvale_brochure_v3.pptx
@@ -938,7 +938,7 @@
                 </a:solidFill>
                 <a:latin typeface="Nimbus Roman"/>
               </a:rPr>
-              <a:t>Expansive view of the open yard and surrounding green space for everyday calm.</a:t>
+              <a:t>Expansive backyard with mountain backdrop, perfect for entertaining, play, and weekend.</a:t>
             </a:r>
             <a:endParaRPr lang="en-CA" sz="1000" b="0" u="none" strike="noStrike">
               <a:solidFill>
@@ -994,7 +994,7 @@
                 </a:solidFill>
                 <a:latin typeface="Nimbus Roman"/>
               </a:rPr>
-              <a:t>Bright dining room connected to the kitchen with windows framing garden views.</a:t>
+              <a:t>Comfortable living room with a large window and cozy setup for relaxing evenings at home.</a:t>
             </a:r>
             <a:endParaRPr lang="en-CA" sz="1000" b="0" u="none" strike="noStrike">
               <a:solidFill>
@@ -1050,7 +1050,7 @@
                 </a:solidFill>
                 <a:latin typeface="Nimbus Roman"/>
               </a:rPr>
-              <a:t>Clean, bright kitchen with generous counter space and modern lighting throughout.</a:t>
+              <a:t>Dining area with sliding-door access and an open flow into the kitchen for easy living.</a:t>
             </a:r>
             <a:endParaRPr lang="en-CA" sz="1000" b="0" u="none" strike="noStrike">
               <a:solidFill>
@@ -1106,7 +1106,7 @@
                 </a:solidFill>
                 <a:latin typeface="Nimbus Roman"/>
               </a:rPr>
-              <a:t>Inviting deck ideal for outdoor dining with a relaxing look over the greenery.</a:t>
+              <a:t>Bright, modern kitchen with spacious countertops, light cabinetry, and stainless appliances.</a:t>
             </a:r>
             <a:endParaRPr lang="en-CA" sz="1000" b="0" u="none" strike="noStrike">
               <a:solidFill>
@@ -1162,7 +1162,7 @@
                 </a:solidFill>
                 <a:latin typeface="Nimbus Roman"/>
               </a:rPr>
-              <a:t>Welcoming front exterior with driveway access and a tidy, attractive façade.</a:t>
+              <a:t>Primary bedroom with a stylish upholstered headboard, soft lighting, and calming room to.</a:t>
             </a:r>
             <a:endParaRPr lang="en-CA" sz="1000" b="0" u="none" strike="noStrike">
               <a:solidFill>
@@ -1276,7 +1276,7 @@
                 </a:solidFill>
                 <a:latin typeface="Nimbus Roman"/>
               </a:rPr>
-              <a:t>Enjoy 1,721 sq. ft. in a bright 3-level split townhome on desirable Happyvale Avenue, offering easy flow between everyday spaces and room to spread out.</a:t>
+              <a:t>Enjoy over 1,700 sq ft across three levels, ready for work, play, and everyday comfort in Brocklehurst.</a:t>
             </a:r>
             <a:endParaRPr lang="en-CA" sz="1100" b="0" u="none" strike="noStrike">
               <a:solidFill>
@@ -1309,7 +1309,7 @@
                 </a:solidFill>
                 <a:latin typeface="Nimbus Roman"/>
               </a:rPr>
-              <a:t>Renovated in 2012 with thoughtful upgrades including kitchen, flooring, appliances, windows, roof, and modern lighting, switches, decks, and railings throughout.</a:t>
+              <a:t>Renovated in 2012 with modern updates including kitchen, flooring, appliances, windows, roof, and refreshed lighting.</a:t>
             </a:r>
           </a:p>
           <a:p>
@@ -1334,7 +1334,7 @@
                 </a:solidFill>
                 <a:latin typeface="Nimbus Roman"/>
               </a:rPr>
-              <a:t>Dine in a sunny main-floor space that opens to a sundeck, where you can overlook your fenced backyard and the peaceful green space beyond.</a:t>
+              <a:t>Dine with ease as the main-floor dining room opens to a sundeck and fenced backyard with green-space views.</a:t>
             </a:r>
           </a:p>
           <a:p>
@@ -1359,7 +1359,7 @@
                 </a:solidFill>
                 <a:latin typeface="Nimbus Roman"/>
               </a:rPr>
-              <a:t>Park with confidence using a double attached garage plus workshop area and pass-through access to the rear yard for extra convenience and storage.</a:t>
+              <a:t>Main-floor laundry plus a generous rec room and flexible basement bedroom make hosting and home offices effortless.</a:t>
             </a:r>
           </a:p>
           <a:p>
@@ -1384,7 +1384,7 @@
                 </a:solidFill>
                 <a:latin typeface="Nimbus Roman"/>
               </a:rPr>
-              <a:t>Stay comfortable year-round with forced air and central air, alongside municipal water and public sewer services for dependable, low-maintenance living.</a:t>
+              <a:t>Double garage with workshop space and pass-through access supports storage, hobbies, and smooth yard use.</a:t>
             </a:r>
           </a:p>
           <a:p>
@@ -1409,32 +1409,7 @@
                 </a:solidFill>
                 <a:latin typeface="Nimbus Roman"/>
               </a:rPr>
-              <a:t>Pet- and rental-friendly strata living keeps life simple, with a fee that covers reserves, insurance, maintenance, management, sewer, snow removal, trash, and water.</a:t>
-            </a:r>
-          </a:p>
-          <a:p>
-            <a:pPr marL="216000" indent="-216000">
-              <a:spcBef>
-                <a:spcPts val="600"/>
-              </a:spcBef>
-              <a:spcAft>
-                <a:spcPts val="0"/>
-              </a:spcAft>
-              <a:buClr>
-                <a:srgbClr val="000000"/>
-              </a:buClr>
-              <a:buSzPct val="70000"/>
-              <a:buFont typeface="Wingdings" charset="2"/>
-              <a:buChar char=""/>
-            </a:pPr>
-            <a:r>
-              <a:rPr b="1" i="1" sz="1100">
-                <a:solidFill>
-                  <a:srgbClr val="000000"/>
-                </a:solidFill>
-                <a:latin typeface="Nimbus Roman"/>
-              </a:rPr>
-              <a:t>Backed by school district land operating as a daycare, the home offers a calm, family-friendly setting near schools, shopping, McArthur Island Park, and River’s Trail.</a:t>
+              <a:t>Four total parking spaces include two in the garage, one in the driveway, and one assigned stall for convenience.</a:t>
             </a:r>
           </a:p>
         </p:txBody>
@@ -1516,7 +1491,7 @@
                 </a:solidFill>
                 <a:latin typeface="Nimbus Roman"/>
               </a:rPr>
-              <a:t>Bright Brocklehurst Townhome Living With Double Garage and Greenbelt Views</a:t>
+              <a:t>Renovated Brocklehurst Home With Cathedral Entry and Private Backyard</a:t>
             </a:r>
             <a:endParaRPr lang="en-CA" sz="1600" b="0" u="none" strike="noStrike">
               <a:solidFill>
@@ -1646,7 +1621,7 @@
       </p:pic>
       <p:pic>
         <p:nvPicPr>
-          <p:cNvPr id="29" name="Picture 28" descr="DSC03378.jpg"/>
+          <p:cNvPr id="29" name="Picture 28" descr="DSC03369.jpg"/>
           <p:cNvPicPr>
             <a:picLocks noChangeAspect="1"/>
           </p:cNvPicPr>
@@ -1671,7 +1646,7 @@
       </p:pic>
       <p:pic>
         <p:nvPicPr>
-          <p:cNvPr id="30" name="Picture 29" descr="DSC03388.jpg"/>
+          <p:cNvPr id="30" name="Picture 29" descr="DSC03387.jpg"/>
           <p:cNvPicPr>
             <a:picLocks noChangeAspect="1"/>
           </p:cNvPicPr>
@@ -1696,7 +1671,7 @@
       </p:pic>
       <p:pic>
         <p:nvPicPr>
-          <p:cNvPr id="31" name="Picture 30" descr="DSC03381.jpg"/>
+          <p:cNvPr id="31" name="Picture 30" descr="DSC03378.jpg"/>
           <p:cNvPicPr>
             <a:picLocks noChangeAspect="1"/>
           </p:cNvPicPr>
@@ -1721,7 +1696,7 @@
       </p:pic>
       <p:pic>
         <p:nvPicPr>
-          <p:cNvPr id="32" name="Picture 31" descr="DSC03442.jpg"/>
+          <p:cNvPr id="32" name="Picture 31" descr="DSC03411.jpg"/>
           <p:cNvPicPr>
             <a:picLocks noChangeAspect="1"/>
           </p:cNvPicPr>
@@ -1729,7 +1704,7 @@
         </p:nvPicPr>
         <p:blipFill>
           <a:blip r:embed="rId7"/>
-          <a:srcRect l="7442" r="7442"/>
+          <a:srcRect l="7541" r="7541"/>
           <a:stretch>
             <a:fillRect/>
           </a:stretch>
@@ -1839,7 +1814,7 @@
                 </a:solidFill>
                 <a:latin typeface="Nimbus Roman"/>
               </a:rPr>
-              <a:t>Comfortable living room with a cozy media setup and a large window for light.</a:t>
+              <a:t>Relax on the covered deck overlooking mature trees, an inviting spot for outdoor dining.</a:t>
             </a:r>
             <a:endParaRPr lang="en-CA" sz="1000" b="0" u="none" strike="noStrike">
               <a:solidFill>
@@ -1895,7 +1870,7 @@
                 </a:solidFill>
                 <a:latin typeface="Nimbus Roman"/>
               </a:rPr>
-              <a:t>Stylish primary bedroom with a plush headboard, soft lighting, and natural brightness.</a:t>
+              <a:t>Bright, refined bathroom vanity with dual lighting for a clean, refreshed daily routine.</a:t>
             </a:r>
             <a:endParaRPr lang="en-CA" sz="1000" b="0" u="none" strike="noStrike">
               <a:solidFill>
@@ -1951,7 +1926,7 @@
                 </a:solidFill>
                 <a:latin typeface="Nimbus Roman"/>
               </a:rPr>
-              <a:t>Inviting rec room on the lower level with space to unwind, play, or work.</a:t>
+              <a:t>Great curb appeal from the driveway with attractive frontage and room for outdoor living.</a:t>
             </a:r>
             <a:endParaRPr lang="en-CA" sz="1000" b="0" u="none" strike="noStrike">
               <a:solidFill>
@@ -2007,7 +1982,7 @@
                 </a:solidFill>
                 <a:latin typeface="Nimbus Roman"/>
               </a:rPr>
-              <a:t>Clean, well-lit full bathroom with an elegant vanity and a bright private shower/tub.</a:t>
+              <a:t>Updated full bathroom with a bright vanity and a clean, tiled shower/tub area.</a:t>
             </a:r>
             <a:endParaRPr lang="en-CA" sz="1000" b="0" u="none" strike="noStrike">
               <a:solidFill>
@@ -2063,7 +2038,7 @@
                 </a:solidFill>
                 <a:latin typeface="Nimbus Roman"/>
               </a:rPr>
-              <a:t>Bright living area with big windows and plenty of seating for gatherings.</a:t>
+              <a:t>Bright living room with comfortable seating and direct access outdoors for effortless.</a:t>
             </a:r>
             <a:endParaRPr lang="en-CA" sz="1000" b="0" u="none" strike="noStrike">
               <a:solidFill>
@@ -2207,39 +2182,6 @@
               </a:lnSpc>
               <a:spcBef>
                 <a:spcPts val="0"/>
-              </a:spcBef>
-              <a:tabLst>
-                <a:tab algn="l" pos="0"/>
-                <a:tab algn="l" pos="347040"/>
-                <a:tab algn="l" pos="898200"/>
-                <a:tab algn="l" pos="4027680"/>
-              </a:tabLst>
-            </a:pPr>
-            <a:r>
-              <a:rPr b="1" sz="1400">
-                <a:solidFill>
-                  <a:srgbClr val="000000"/>
-                </a:solidFill>
-                <a:latin typeface="Nimbus Roman"/>
-              </a:rPr>
-              <a:t>Location:	Brocklehurst</a:t>
-            </a:r>
-            <a:endParaRPr lang="en-CA" sz="1400" b="0" u="none" strike="noStrike">
-              <a:solidFill>
-                <a:srgbClr val="000000"/>
-              </a:solidFill>
-              <a:effectLst/>
-              <a:uFillTx/>
-              <a:latin typeface="Arial"/>
-            </a:endParaRPr>
-          </a:p>
-          <a:p>
-            <a:pPr>
-              <a:lnSpc>
-                <a:spcPct val="200000"/>
-              </a:lnSpc>
-              <a:spcBef>
-                <a:spcPts val="700"/>
               </a:spcBef>
               <a:spcAft>
                 <a:spcPts val="0"/>
@@ -2258,8 +2200,16 @@
                 </a:solidFill>
                 <a:latin typeface="Nimbus Roman"/>
               </a:rPr>
-              <a:t>Style:	Cathedral Entry</a:t>
-            </a:r>
+              <a:t>Location:	Brocklehurst</a:t>
+            </a:r>
+            <a:endParaRPr lang="en-CA" sz="1400" b="0" u="none" strike="noStrike">
+              <a:solidFill>
+                <a:srgbClr val="000000"/>
+              </a:solidFill>
+              <a:effectLst/>
+              <a:uFillTx/>
+              <a:latin typeface="Arial"/>
+            </a:endParaRPr>
           </a:p>
           <a:p>
             <a:pPr>
@@ -2267,7 +2217,7 @@
                 <a:spcPct val="200000"/>
               </a:lnSpc>
               <a:spcBef>
-                <a:spcPts val="700"/>
+                <a:spcPts val="440"/>
               </a:spcBef>
               <a:spcAft>
                 <a:spcPts val="0"/>
@@ -2286,7 +2236,7 @@
                 </a:solidFill>
                 <a:latin typeface="Nimbus Roman"/>
               </a:rPr>
-              <a:t>Heating:	Forced Air</a:t>
+              <a:t>Style:		Cathedral Entry</a:t>
             </a:r>
           </a:p>
           <a:p>
@@ -2295,7 +2245,7 @@
                 <a:spcPct val="200000"/>
               </a:lnSpc>
               <a:spcBef>
-                <a:spcPts val="350"/>
+                <a:spcPts val="440"/>
               </a:spcBef>
               <a:spcAft>
                 <a:spcPts val="0"/>
@@ -2314,7 +2264,7 @@
                 </a:solidFill>
                 <a:latin typeface="Nimbus Roman"/>
               </a:rPr>
-              <a:t>	Central Air</a:t>
+              <a:t>Heating:	Forced Air</a:t>
             </a:r>
           </a:p>
           <a:p>
@@ -2323,7 +2273,7 @@
                 <a:spcPct val="200000"/>
               </a:lnSpc>
               <a:spcBef>
-                <a:spcPts val="700"/>
+                <a:spcPts val="220"/>
               </a:spcBef>
               <a:spcAft>
                 <a:spcPts val="0"/>
@@ -2342,7 +2292,7 @@
                 </a:solidFill>
                 <a:latin typeface="Nimbus Roman"/>
               </a:rPr>
-              <a:t>Includes:	Dishwasher</a:t>
+              <a:t>		Central Air</a:t>
             </a:r>
           </a:p>
           <a:p>
@@ -2351,7 +2301,7 @@
                 <a:spcPct val="200000"/>
               </a:lnSpc>
               <a:spcBef>
-                <a:spcPts val="350"/>
+                <a:spcPts val="440"/>
               </a:spcBef>
               <a:spcAft>
                 <a:spcPts val="0"/>
@@ -2370,7 +2320,7 @@
                 </a:solidFill>
                 <a:latin typeface="Nimbus Roman"/>
               </a:rPr>
-              <a:t>	Electric Range</a:t>
+              <a:t>Parking:	2 Car Garage</a:t>
             </a:r>
           </a:p>
           <a:p>
@@ -2379,7 +2329,7 @@
                 <a:spcPct val="200000"/>
               </a:lnSpc>
               <a:spcBef>
-                <a:spcPts val="350"/>
+                <a:spcPts val="440"/>
               </a:spcBef>
               <a:spcAft>
                 <a:spcPts val="0"/>
@@ -2398,7 +2348,7 @@
                 </a:solidFill>
                 <a:latin typeface="Nimbus Roman"/>
               </a:rPr>
-              <a:t>	Refrigerator</a:t>
+              <a:t>Includes:	Dishwasher</a:t>
             </a:r>
           </a:p>
           <a:p>
@@ -2407,7 +2357,7 @@
                 <a:spcPct val="200000"/>
               </a:lnSpc>
               <a:spcBef>
-                <a:spcPts val="350"/>
+                <a:spcPts val="220"/>
               </a:spcBef>
               <a:spcAft>
                 <a:spcPts val="0"/>
@@ -2426,7 +2376,7 @@
                 </a:solidFill>
                 <a:latin typeface="Nimbus Roman"/>
               </a:rPr>
-              <a:t>	Washer/Dryer</a:t>
+              <a:t>		Electric Range</a:t>
             </a:r>
           </a:p>
           <a:p>
@@ -2435,7 +2385,7 @@
                 <a:spcPct val="200000"/>
               </a:lnSpc>
               <a:spcBef>
-                <a:spcPts val="350"/>
+                <a:spcPts val="220"/>
               </a:spcBef>
               <a:spcAft>
                 <a:spcPts val="0"/>
@@ -2454,7 +2404,7 @@
                 </a:solidFill>
                 <a:latin typeface="Nimbus Roman"/>
               </a:rPr>
-              <a:t>	Deck</a:t>
+              <a:t>		Refrigerator</a:t>
             </a:r>
           </a:p>
           <a:p>
@@ -2463,7 +2413,7 @@
                 <a:spcPct val="200000"/>
               </a:lnSpc>
               <a:spcBef>
-                <a:spcPts val="350"/>
+                <a:spcPts val="220"/>
               </a:spcBef>
               <a:spcAft>
                 <a:spcPts val="0"/>
@@ -2482,7 +2432,7 @@
                 </a:solidFill>
                 <a:latin typeface="Nimbus Roman"/>
               </a:rPr>
-              <a:t>	Private Yard</a:t>
+              <a:t>		Washer/Dryer</a:t>
             </a:r>
           </a:p>
           <a:p>
@@ -2491,7 +2441,7 @@
                 <a:spcPct val="200000"/>
               </a:lnSpc>
               <a:spcBef>
-                <a:spcPts val="700"/>
+                <a:spcPts val="220"/>
               </a:spcBef>
               <a:spcAft>
                 <a:spcPts val="0"/>
@@ -2510,7 +2460,7 @@
                 </a:solidFill>
                 <a:latin typeface="Nimbus Roman"/>
               </a:rPr>
-              <a:t>Taxes:	$3,145 (2025)</a:t>
+              <a:t>		Deck</a:t>
             </a:r>
           </a:p>
           <a:p>
@@ -2519,7 +2469,7 @@
                 <a:spcPct val="200000"/>
               </a:lnSpc>
               <a:spcBef>
-                <a:spcPts val="700"/>
+                <a:spcPts val="220"/>
               </a:spcBef>
               <a:spcAft>
                 <a:spcPts val="0"/>
@@ -2538,7 +2488,63 @@
                 </a:solidFill>
                 <a:latin typeface="Nimbus Roman"/>
               </a:rPr>
-              <a:t>Lot Size:	Lot Acres not provided</a:t>
+              <a:t>		Private Yard</a:t>
+            </a:r>
+          </a:p>
+          <a:p>
+            <a:pPr>
+              <a:lnSpc>
+                <a:spcPct val="200000"/>
+              </a:lnSpc>
+              <a:spcBef>
+                <a:spcPts val="440"/>
+              </a:spcBef>
+              <a:spcAft>
+                <a:spcPts val="0"/>
+              </a:spcAft>
+              <a:tabLst>
+                <a:tab algn="l" pos="0"/>
+                <a:tab algn="l" pos="347040"/>
+                <a:tab algn="l" pos="898200"/>
+                <a:tab algn="l" pos="4027680"/>
+              </a:tabLst>
+            </a:pPr>
+            <a:r>
+              <a:rPr b="1" sz="1400">
+                <a:solidFill>
+                  <a:srgbClr val="000000"/>
+                </a:solidFill>
+                <a:latin typeface="Nimbus Roman"/>
+              </a:rPr>
+              <a:t>Taxes:		$3,145 (2025)</a:t>
+            </a:r>
+          </a:p>
+          <a:p>
+            <a:pPr>
+              <a:lnSpc>
+                <a:spcPct val="200000"/>
+              </a:lnSpc>
+              <a:spcBef>
+                <a:spcPts val="440"/>
+              </a:spcBef>
+              <a:spcAft>
+                <a:spcPts val="0"/>
+              </a:spcAft>
+              <a:tabLst>
+                <a:tab algn="l" pos="0"/>
+                <a:tab algn="l" pos="347040"/>
+                <a:tab algn="l" pos="898200"/>
+                <a:tab algn="l" pos="4027680"/>
+              </a:tabLst>
+            </a:pPr>
+            <a:r>
+              <a:rPr b="1" sz="1400">
+                <a:solidFill>
+                  <a:srgbClr val="000000"/>
+                </a:solidFill>
+                <a:latin typeface="Nimbus Roman"/>
+              </a:rPr>
+              <a:t>Lot Size:	Lot size (acres): not provided</a:t>
             </a:r>
           </a:p>
         </p:txBody>
@@ -2610,7 +2616,7 @@
                 </a:solidFill>
                 <a:latin typeface="Nimbus Roman"/>
               </a:rPr>
-              <a:t>Storage	18' 9" x 6'</a:t>
+              <a:t>Lower / Basement bedroom	</a:t>
             </a:r>
           </a:p>
           <a:p>
@@ -2629,7 +2635,7 @@
                 </a:solidFill>
                 <a:latin typeface="Nimbus Roman"/>
               </a:rPr>
-              <a:t>Main (1,046 sq. ft.)</a:t>
+              <a:t>Basement (1046 sq. ft.)</a:t>
             </a:r>
           </a:p>
           <a:p/>
@@ -2744,7 +2750,7 @@
                 </a:solidFill>
                 <a:latin typeface="Nimbus Roman"/>
               </a:rPr>
-              <a:t>Bathroom - Full (4 PCE)	</a:t>
+              <a:t>Bedroom	12' 7" x 12' 9" 8' 9"</a:t>
             </a:r>
           </a:p>
           <a:p>
@@ -2763,7 +2769,7 @@
                 </a:solidFill>
                 <a:latin typeface="Nimbus Roman"/>
               </a:rPr>
-              <a:t>Ensuite - Half (2 PCE)	</a:t>
+              <a:t>Bathroom	4 piece</a:t>
             </a:r>
           </a:p>
           <a:p>
@@ -2782,7 +2788,7 @@
                 </a:solidFill>
                 <a:latin typeface="Nimbus Roman"/>
               </a:rPr>
-              <a:t>Laundry	9' 3" x 3'</a:t>
+              <a:t>Ensuite	2 piece</a:t>
             </a:r>
           </a:p>
           <a:p>
@@ -2801,7 +2807,7 @@
                 </a:solidFill>
                 <a:latin typeface="Nimbus Roman"/>
               </a:rPr>
-              <a:t>Family Room	19' 3" x 12' 6"</a:t>
+              <a:t>Laundry	9' 3" x 3'"</a:t>
             </a:r>
           </a:p>
           <a:p>
@@ -2820,7 +2826,26 @@
                 </a:solidFill>
                 <a:latin typeface="Nimbus Roman"/>
               </a:rPr>
-              <a:t>Bedroom	12' 7" x 12' 9" x 8' 9" x 9' 9"</a:t>
+              <a:t>Family Room	19' 3" x 12' 6"</a:t>
+            </a:r>
+          </a:p>
+          <a:p>
+            <a:pPr>
+              <a:lnSpc>
+                <a:spcPct val="150000"/>
+              </a:lnSpc>
+              <a:tabLst>
+                <a:tab algn="l" pos="1619280"/>
+              </a:tabLst>
+            </a:pPr>
+            <a:r>
+              <a:rPr b="1" sz="1400">
+                <a:solidFill>
+                  <a:srgbClr val="000000"/>
+                </a:solidFill>
+                <a:latin typeface="Nimbus Roman"/>
+              </a:rPr>
+              <a:t>Storage	18' 9" x 6'"</a:t>
             </a:r>
           </a:p>
         </p:txBody>
@@ -2872,7 +2897,7 @@
       </p:sp>
       <p:pic>
         <p:nvPicPr>
-          <p:cNvPr id="43" name="Picture 42" descr="DSC03369.jpg"/>
+          <p:cNvPr id="43" name="Picture 42" descr="DSC03388.jpg"/>
           <p:cNvPicPr>
             <a:picLocks noChangeAspect="1"/>
           </p:cNvPicPr>
@@ -2897,7 +2922,7 @@
       </p:pic>
       <p:pic>
         <p:nvPicPr>
-          <p:cNvPr id="44" name="Picture 43" descr="DSC03411.jpg"/>
+          <p:cNvPr id="44" name="Picture 43" descr="DSC03417.jpg"/>
           <p:cNvPicPr>
             <a:picLocks noChangeAspect="1"/>
           </p:cNvPicPr>
@@ -2922,7 +2947,7 @@
       </p:pic>
       <p:pic>
         <p:nvPicPr>
-          <p:cNvPr id="45" name="Picture 44" descr="DSC03428.jpg"/>
+          <p:cNvPr id="45" name="Picture 44" descr="DSC03442.jpg"/>
           <p:cNvPicPr>
             <a:picLocks noChangeAspect="1"/>
           </p:cNvPicPr>

</xml_diff>